<commit_message>
vault backup: 2026-05-11 12:23:48
</commit_message>
<xml_diff>
--- a/outputs/consulting-slide-solution/pptx/12-ai-workflow-asis-editable.pptx
+++ b/outputs/consulting-slide-solution/pptx/12-ai-workflow-asis-editable.pptx
@@ -5,9 +5,9 @@
     <p:sldMasterId id="2147483648" r:id="rId1"/>
   </p:sldMasterIdLst>
   <p:sldIdLst>
-    <p:sldId id="256" r:id="rId7"/>
+    <p:sldId id="256" r:id="rId2"/>
   </p:sldIdLst>
-  <p:sldSz cx="12191695" cy="6858000" type="screen4x3"/>
+  <p:sldSz cx="12192000" cy="6858000"/>
   <p:notesSz cx="6858000" cy="9144000"/>
   <p:defaultTextStyle>
     <a:defPPr>
@@ -104,6 +104,22 @@
       </a:defRPr>
     </a:lvl9pPr>
   </p:defaultTextStyle>
+  <p:extLst>
+    <p:ext uri="{EFAFB233-063F-42B5-8137-9DF3F51BA10A}">
+      <p15:sldGuideLst xmlns:p15="http://schemas.microsoft.com/office/powerpoint/2012/main">
+        <p15:guide id="1" orient="horz" pos="2160">
+          <p15:clr>
+            <a:srgbClr val="A4A3A4"/>
+          </p15:clr>
+        </p15:guide>
+        <p15:guide id="2" pos="2880">
+          <p15:clr>
+            <a:srgbClr val="A4A3A4"/>
+          </p15:clr>
+        </p15:guide>
+      </p15:sldGuideLst>
+    </p:ext>
+  </p:extLst>
 </p:presentation>
 </file>
 
@@ -145,10 +161,9 @@
           <a:lstStyle/>
           <a:p>
             <a:r>
-              <a:rPr lang="en-US" smtClean="0"/>
+              <a:rPr lang="en-US"/>
               <a:t>Click to edit Master title style</a:t>
             </a:r>
-            <a:endParaRPr lang="en-US"/>
           </a:p>
         </p:txBody>
       </p:sp>
@@ -264,10 +279,9 @@
           </a:lstStyle>
           <a:p>
             <a:r>
-              <a:rPr lang="en-US" smtClean="0"/>
+              <a:rPr lang="en-US"/>
               <a:t>Click to edit Master subtitle style</a:t>
             </a:r>
-            <a:endParaRPr lang="en-US"/>
           </a:p>
         </p:txBody>
       </p:sp>
@@ -288,7 +302,7 @@
           <a:p>
             <a:fld id="{5BCAD085-E8A6-8845-BD4E-CB4CCA059FC4}" type="datetimeFigureOut">
               <a:rPr lang="en-US" smtClean="0"/>
-              <a:t>1/27/13</a:t>
+              <a:t>5/11/26</a:t>
             </a:fld>
             <a:endParaRPr lang="en-US"/>
           </a:p>
@@ -382,10 +396,9 @@
           <a:lstStyle/>
           <a:p>
             <a:r>
-              <a:rPr lang="en-US" smtClean="0"/>
+              <a:rPr lang="en-US"/>
               <a:t>Click to edit Master title style</a:t>
             </a:r>
-            <a:endParaRPr lang="en-US"/>
           </a:p>
         </p:txBody>
       </p:sp>
@@ -406,38 +419,37 @@
           <a:p>
             <a:pPr lvl="0"/>
             <a:r>
-              <a:rPr lang="en-US" smtClean="0"/>
+              <a:rPr lang="en-US"/>
               <a:t>Click to edit Master text styles</a:t>
             </a:r>
           </a:p>
           <a:p>
             <a:pPr lvl="1"/>
             <a:r>
-              <a:rPr lang="en-US" smtClean="0"/>
+              <a:rPr lang="en-US"/>
               <a:t>Second level</a:t>
             </a:r>
           </a:p>
           <a:p>
             <a:pPr lvl="2"/>
             <a:r>
-              <a:rPr lang="en-US" smtClean="0"/>
+              <a:rPr lang="en-US"/>
               <a:t>Third level</a:t>
             </a:r>
           </a:p>
           <a:p>
             <a:pPr lvl="3"/>
             <a:r>
-              <a:rPr lang="en-US" smtClean="0"/>
+              <a:rPr lang="en-US"/>
               <a:t>Fourth level</a:t>
             </a:r>
           </a:p>
           <a:p>
             <a:pPr lvl="4"/>
             <a:r>
-              <a:rPr lang="en-US" smtClean="0"/>
+              <a:rPr lang="en-US"/>
               <a:t>Fifth level</a:t>
             </a:r>
-            <a:endParaRPr lang="en-US"/>
           </a:p>
         </p:txBody>
       </p:sp>
@@ -458,7 +470,7 @@
           <a:p>
             <a:fld id="{5BCAD085-E8A6-8845-BD4E-CB4CCA059FC4}" type="datetimeFigureOut">
               <a:rPr lang="en-US" smtClean="0"/>
-              <a:t>1/27/13</a:t>
+              <a:t>5/11/26</a:t>
             </a:fld>
             <a:endParaRPr lang="en-US"/>
           </a:p>
@@ -557,10 +569,9 @@
           <a:lstStyle/>
           <a:p>
             <a:r>
-              <a:rPr lang="en-US" smtClean="0"/>
+              <a:rPr lang="en-US"/>
               <a:t>Click to edit Master title style</a:t>
             </a:r>
-            <a:endParaRPr lang="en-US"/>
           </a:p>
         </p:txBody>
       </p:sp>
@@ -586,38 +597,37 @@
           <a:p>
             <a:pPr lvl="0"/>
             <a:r>
-              <a:rPr lang="en-US" smtClean="0"/>
+              <a:rPr lang="en-US"/>
               <a:t>Click to edit Master text styles</a:t>
             </a:r>
           </a:p>
           <a:p>
             <a:pPr lvl="1"/>
             <a:r>
-              <a:rPr lang="en-US" smtClean="0"/>
+              <a:rPr lang="en-US"/>
               <a:t>Second level</a:t>
             </a:r>
           </a:p>
           <a:p>
             <a:pPr lvl="2"/>
             <a:r>
-              <a:rPr lang="en-US" smtClean="0"/>
+              <a:rPr lang="en-US"/>
               <a:t>Third level</a:t>
             </a:r>
           </a:p>
           <a:p>
             <a:pPr lvl="3"/>
             <a:r>
-              <a:rPr lang="en-US" smtClean="0"/>
+              <a:rPr lang="en-US"/>
               <a:t>Fourth level</a:t>
             </a:r>
           </a:p>
           <a:p>
             <a:pPr lvl="4"/>
             <a:r>
-              <a:rPr lang="en-US" smtClean="0"/>
+              <a:rPr lang="en-US"/>
               <a:t>Fifth level</a:t>
             </a:r>
-            <a:endParaRPr lang="en-US"/>
           </a:p>
         </p:txBody>
       </p:sp>
@@ -638,7 +648,7 @@
           <a:p>
             <a:fld id="{5BCAD085-E8A6-8845-BD4E-CB4CCA059FC4}" type="datetimeFigureOut">
               <a:rPr lang="en-US" smtClean="0"/>
-              <a:t>1/27/13</a:t>
+              <a:t>5/11/26</a:t>
             </a:fld>
             <a:endParaRPr lang="en-US"/>
           </a:p>
@@ -732,10 +742,9 @@
           <a:lstStyle/>
           <a:p>
             <a:r>
-              <a:rPr lang="en-US" smtClean="0"/>
+              <a:rPr lang="en-US"/>
               <a:t>Click to edit Master title style</a:t>
             </a:r>
-            <a:endParaRPr lang="en-US"/>
           </a:p>
         </p:txBody>
       </p:sp>
@@ -756,38 +765,37 @@
           <a:p>
             <a:pPr lvl="0"/>
             <a:r>
-              <a:rPr lang="en-US" smtClean="0"/>
+              <a:rPr lang="en-US"/>
               <a:t>Click to edit Master text styles</a:t>
             </a:r>
           </a:p>
           <a:p>
             <a:pPr lvl="1"/>
             <a:r>
-              <a:rPr lang="en-US" smtClean="0"/>
+              <a:rPr lang="en-US"/>
               <a:t>Second level</a:t>
             </a:r>
           </a:p>
           <a:p>
             <a:pPr lvl="2"/>
             <a:r>
-              <a:rPr lang="en-US" smtClean="0"/>
+              <a:rPr lang="en-US"/>
               <a:t>Third level</a:t>
             </a:r>
           </a:p>
           <a:p>
             <a:pPr lvl="3"/>
             <a:r>
-              <a:rPr lang="en-US" smtClean="0"/>
+              <a:rPr lang="en-US"/>
               <a:t>Fourth level</a:t>
             </a:r>
           </a:p>
           <a:p>
             <a:pPr lvl="4"/>
             <a:r>
-              <a:rPr lang="en-US" smtClean="0"/>
+              <a:rPr lang="en-US"/>
               <a:t>Fifth level</a:t>
             </a:r>
-            <a:endParaRPr lang="en-US"/>
           </a:p>
         </p:txBody>
       </p:sp>
@@ -808,7 +816,7 @@
           <a:p>
             <a:fld id="{5BCAD085-E8A6-8845-BD4E-CB4CCA059FC4}" type="datetimeFigureOut">
               <a:rPr lang="en-US" smtClean="0"/>
-              <a:t>1/27/13</a:t>
+              <a:t>5/11/26</a:t>
             </a:fld>
             <a:endParaRPr lang="en-US"/>
           </a:p>
@@ -911,10 +919,9 @@
           </a:lstStyle>
           <a:p>
             <a:r>
-              <a:rPr lang="en-US" smtClean="0"/>
+              <a:rPr lang="en-US"/>
               <a:t>Click to edit Master title style</a:t>
             </a:r>
-            <a:endParaRPr lang="en-US"/>
           </a:p>
         </p:txBody>
       </p:sp>
@@ -1031,7 +1038,7 @@
           <a:p>
             <a:pPr lvl="0"/>
             <a:r>
-              <a:rPr lang="en-US" smtClean="0"/>
+              <a:rPr lang="en-US"/>
               <a:t>Click to edit Master text styles</a:t>
             </a:r>
           </a:p>
@@ -1054,7 +1061,7 @@
           <a:p>
             <a:fld id="{5BCAD085-E8A6-8845-BD4E-CB4CCA059FC4}" type="datetimeFigureOut">
               <a:rPr lang="en-US" smtClean="0"/>
-              <a:t>1/27/13</a:t>
+              <a:t>5/11/26</a:t>
             </a:fld>
             <a:endParaRPr lang="en-US"/>
           </a:p>
@@ -1148,10 +1155,9 @@
           <a:lstStyle/>
           <a:p>
             <a:r>
-              <a:rPr lang="en-US" smtClean="0"/>
+              <a:rPr lang="en-US"/>
               <a:t>Click to edit Master title style</a:t>
             </a:r>
-            <a:endParaRPr lang="en-US"/>
           </a:p>
         </p:txBody>
       </p:sp>
@@ -1205,38 +1211,37 @@
           <a:p>
             <a:pPr lvl="0"/>
             <a:r>
-              <a:rPr lang="en-US" smtClean="0"/>
+              <a:rPr lang="en-US"/>
               <a:t>Click to edit Master text styles</a:t>
             </a:r>
           </a:p>
           <a:p>
             <a:pPr lvl="1"/>
             <a:r>
-              <a:rPr lang="en-US" smtClean="0"/>
+              <a:rPr lang="en-US"/>
               <a:t>Second level</a:t>
             </a:r>
           </a:p>
           <a:p>
             <a:pPr lvl="2"/>
             <a:r>
-              <a:rPr lang="en-US" smtClean="0"/>
+              <a:rPr lang="en-US"/>
               <a:t>Third level</a:t>
             </a:r>
           </a:p>
           <a:p>
             <a:pPr lvl="3"/>
             <a:r>
-              <a:rPr lang="en-US" smtClean="0"/>
+              <a:rPr lang="en-US"/>
               <a:t>Fourth level</a:t>
             </a:r>
           </a:p>
           <a:p>
             <a:pPr lvl="4"/>
             <a:r>
-              <a:rPr lang="en-US" smtClean="0"/>
+              <a:rPr lang="en-US"/>
               <a:t>Fifth level</a:t>
             </a:r>
-            <a:endParaRPr lang="en-US"/>
           </a:p>
         </p:txBody>
       </p:sp>
@@ -1290,38 +1295,37 @@
           <a:p>
             <a:pPr lvl="0"/>
             <a:r>
-              <a:rPr lang="en-US" smtClean="0"/>
+              <a:rPr lang="en-US"/>
               <a:t>Click to edit Master text styles</a:t>
             </a:r>
           </a:p>
           <a:p>
             <a:pPr lvl="1"/>
             <a:r>
-              <a:rPr lang="en-US" smtClean="0"/>
+              <a:rPr lang="en-US"/>
               <a:t>Second level</a:t>
             </a:r>
           </a:p>
           <a:p>
             <a:pPr lvl="2"/>
             <a:r>
-              <a:rPr lang="en-US" smtClean="0"/>
+              <a:rPr lang="en-US"/>
               <a:t>Third level</a:t>
             </a:r>
           </a:p>
           <a:p>
             <a:pPr lvl="3"/>
             <a:r>
-              <a:rPr lang="en-US" smtClean="0"/>
+              <a:rPr lang="en-US"/>
               <a:t>Fourth level</a:t>
             </a:r>
           </a:p>
           <a:p>
             <a:pPr lvl="4"/>
             <a:r>
-              <a:rPr lang="en-US" smtClean="0"/>
+              <a:rPr lang="en-US"/>
               <a:t>Fifth level</a:t>
             </a:r>
-            <a:endParaRPr lang="en-US"/>
           </a:p>
         </p:txBody>
       </p:sp>
@@ -1342,7 +1346,7 @@
           <a:p>
             <a:fld id="{5BCAD085-E8A6-8845-BD4E-CB4CCA059FC4}" type="datetimeFigureOut">
               <a:rPr lang="en-US" smtClean="0"/>
-              <a:t>1/27/13</a:t>
+              <a:t>5/11/26</a:t>
             </a:fld>
             <a:endParaRPr lang="en-US"/>
           </a:p>
@@ -1440,10 +1444,9 @@
           </a:lstStyle>
           <a:p>
             <a:r>
-              <a:rPr lang="en-US" smtClean="0"/>
+              <a:rPr lang="en-US"/>
               <a:t>Click to edit Master title style</a:t>
             </a:r>
-            <a:endParaRPr lang="en-US"/>
           </a:p>
         </p:txBody>
       </p:sp>
@@ -1506,7 +1509,7 @@
           <a:p>
             <a:pPr lvl="0"/>
             <a:r>
-              <a:rPr lang="en-US" smtClean="0"/>
+              <a:rPr lang="en-US"/>
               <a:t>Click to edit Master text styles</a:t>
             </a:r>
           </a:p>
@@ -1562,38 +1565,37 @@
           <a:p>
             <a:pPr lvl="0"/>
             <a:r>
-              <a:rPr lang="en-US" smtClean="0"/>
+              <a:rPr lang="en-US"/>
               <a:t>Click to edit Master text styles</a:t>
             </a:r>
           </a:p>
           <a:p>
             <a:pPr lvl="1"/>
             <a:r>
-              <a:rPr lang="en-US" smtClean="0"/>
+              <a:rPr lang="en-US"/>
               <a:t>Second level</a:t>
             </a:r>
           </a:p>
           <a:p>
             <a:pPr lvl="2"/>
             <a:r>
-              <a:rPr lang="en-US" smtClean="0"/>
+              <a:rPr lang="en-US"/>
               <a:t>Third level</a:t>
             </a:r>
           </a:p>
           <a:p>
             <a:pPr lvl="3"/>
             <a:r>
-              <a:rPr lang="en-US" smtClean="0"/>
+              <a:rPr lang="en-US"/>
               <a:t>Fourth level</a:t>
             </a:r>
           </a:p>
           <a:p>
             <a:pPr lvl="4"/>
             <a:r>
-              <a:rPr lang="en-US" smtClean="0"/>
+              <a:rPr lang="en-US"/>
               <a:t>Fifth level</a:t>
             </a:r>
-            <a:endParaRPr lang="en-US"/>
           </a:p>
         </p:txBody>
       </p:sp>
@@ -1656,7 +1658,7 @@
           <a:p>
             <a:pPr lvl="0"/>
             <a:r>
-              <a:rPr lang="en-US" smtClean="0"/>
+              <a:rPr lang="en-US"/>
               <a:t>Click to edit Master text styles</a:t>
             </a:r>
           </a:p>
@@ -1712,38 +1714,37 @@
           <a:p>
             <a:pPr lvl="0"/>
             <a:r>
-              <a:rPr lang="en-US" smtClean="0"/>
+              <a:rPr lang="en-US"/>
               <a:t>Click to edit Master text styles</a:t>
             </a:r>
           </a:p>
           <a:p>
             <a:pPr lvl="1"/>
             <a:r>
-              <a:rPr lang="en-US" smtClean="0"/>
+              <a:rPr lang="en-US"/>
               <a:t>Second level</a:t>
             </a:r>
           </a:p>
           <a:p>
             <a:pPr lvl="2"/>
             <a:r>
-              <a:rPr lang="en-US" smtClean="0"/>
+              <a:rPr lang="en-US"/>
               <a:t>Third level</a:t>
             </a:r>
           </a:p>
           <a:p>
             <a:pPr lvl="3"/>
             <a:r>
-              <a:rPr lang="en-US" smtClean="0"/>
+              <a:rPr lang="en-US"/>
               <a:t>Fourth level</a:t>
             </a:r>
           </a:p>
           <a:p>
             <a:pPr lvl="4"/>
             <a:r>
-              <a:rPr lang="en-US" smtClean="0"/>
+              <a:rPr lang="en-US"/>
               <a:t>Fifth level</a:t>
             </a:r>
-            <a:endParaRPr lang="en-US"/>
           </a:p>
         </p:txBody>
       </p:sp>
@@ -1764,7 +1765,7 @@
           <a:p>
             <a:fld id="{5BCAD085-E8A6-8845-BD4E-CB4CCA059FC4}" type="datetimeFigureOut">
               <a:rPr lang="en-US" smtClean="0"/>
-              <a:t>1/27/13</a:t>
+              <a:t>5/11/26</a:t>
             </a:fld>
             <a:endParaRPr lang="en-US"/>
           </a:p>
@@ -1858,10 +1859,9 @@
           <a:lstStyle/>
           <a:p>
             <a:r>
-              <a:rPr lang="en-US" smtClean="0"/>
+              <a:rPr lang="en-US"/>
               <a:t>Click to edit Master title style</a:t>
             </a:r>
-            <a:endParaRPr lang="en-US"/>
           </a:p>
         </p:txBody>
       </p:sp>
@@ -1882,7 +1882,7 @@
           <a:p>
             <a:fld id="{5BCAD085-E8A6-8845-BD4E-CB4CCA059FC4}" type="datetimeFigureOut">
               <a:rPr lang="en-US" smtClean="0"/>
-              <a:t>1/27/13</a:t>
+              <a:t>5/11/26</a:t>
             </a:fld>
             <a:endParaRPr lang="en-US"/>
           </a:p>
@@ -1977,7 +1977,7 @@
           <a:p>
             <a:fld id="{5BCAD085-E8A6-8845-BD4E-CB4CCA059FC4}" type="datetimeFigureOut">
               <a:rPr lang="en-US" smtClean="0"/>
-              <a:t>1/27/13</a:t>
+              <a:t>5/11/26</a:t>
             </a:fld>
             <a:endParaRPr lang="en-US"/>
           </a:p>
@@ -2080,10 +2080,9 @@
           </a:lstStyle>
           <a:p>
             <a:r>
-              <a:rPr lang="en-US" smtClean="0"/>
+              <a:rPr lang="en-US"/>
               <a:t>Click to edit Master title style</a:t>
             </a:r>
-            <a:endParaRPr lang="en-US"/>
           </a:p>
         </p:txBody>
       </p:sp>
@@ -2137,38 +2136,37 @@
           <a:p>
             <a:pPr lvl="0"/>
             <a:r>
-              <a:rPr lang="en-US" smtClean="0"/>
+              <a:rPr lang="en-US"/>
               <a:t>Click to edit Master text styles</a:t>
             </a:r>
           </a:p>
           <a:p>
             <a:pPr lvl="1"/>
             <a:r>
-              <a:rPr lang="en-US" smtClean="0"/>
+              <a:rPr lang="en-US"/>
               <a:t>Second level</a:t>
             </a:r>
           </a:p>
           <a:p>
             <a:pPr lvl="2"/>
             <a:r>
-              <a:rPr lang="en-US" smtClean="0"/>
+              <a:rPr lang="en-US"/>
               <a:t>Third level</a:t>
             </a:r>
           </a:p>
           <a:p>
             <a:pPr lvl="3"/>
             <a:r>
-              <a:rPr lang="en-US" smtClean="0"/>
+              <a:rPr lang="en-US"/>
               <a:t>Fourth level</a:t>
             </a:r>
           </a:p>
           <a:p>
             <a:pPr lvl="4"/>
             <a:r>
-              <a:rPr lang="en-US" smtClean="0"/>
+              <a:rPr lang="en-US"/>
               <a:t>Fifth level</a:t>
             </a:r>
-            <a:endParaRPr lang="en-US"/>
           </a:p>
         </p:txBody>
       </p:sp>
@@ -2231,7 +2229,7 @@
           <a:p>
             <a:pPr lvl="0"/>
             <a:r>
-              <a:rPr lang="en-US" smtClean="0"/>
+              <a:rPr lang="en-US"/>
               <a:t>Click to edit Master text styles</a:t>
             </a:r>
           </a:p>
@@ -2254,7 +2252,7 @@
           <a:p>
             <a:fld id="{5BCAD085-E8A6-8845-BD4E-CB4CCA059FC4}" type="datetimeFigureOut">
               <a:rPr lang="en-US" smtClean="0"/>
-              <a:t>1/27/13</a:t>
+              <a:t>5/11/26</a:t>
             </a:fld>
             <a:endParaRPr lang="en-US"/>
           </a:p>
@@ -2357,10 +2355,9 @@
           </a:lstStyle>
           <a:p>
             <a:r>
-              <a:rPr lang="en-US" smtClean="0"/>
+              <a:rPr lang="en-US"/>
               <a:t>Click to edit Master title style</a:t>
             </a:r>
-            <a:endParaRPr lang="en-US"/>
           </a:p>
         </p:txBody>
       </p:sp>
@@ -2484,7 +2481,7 @@
           <a:p>
             <a:pPr lvl="0"/>
             <a:r>
-              <a:rPr lang="en-US" smtClean="0"/>
+              <a:rPr lang="en-US"/>
               <a:t>Click to edit Master text styles</a:t>
             </a:r>
           </a:p>
@@ -2507,7 +2504,7 @@
           <a:p>
             <a:fld id="{5BCAD085-E8A6-8845-BD4E-CB4CCA059FC4}" type="datetimeFigureOut">
               <a:rPr lang="en-US" smtClean="0"/>
-              <a:t>1/27/13</a:t>
+              <a:t>5/11/26</a:t>
             </a:fld>
             <a:endParaRPr lang="en-US"/>
           </a:p>
@@ -2616,10 +2613,9 @@
           <a:lstStyle/>
           <a:p>
             <a:r>
-              <a:rPr lang="en-US" smtClean="0"/>
+              <a:rPr lang="en-US"/>
               <a:t>Click to edit Master title style</a:t>
             </a:r>
-            <a:endParaRPr lang="en-US"/>
           </a:p>
         </p:txBody>
       </p:sp>
@@ -2650,38 +2646,37 @@
           <a:p>
             <a:pPr lvl="0"/>
             <a:r>
-              <a:rPr lang="en-US" smtClean="0"/>
+              <a:rPr lang="en-US"/>
               <a:t>Click to edit Master text styles</a:t>
             </a:r>
           </a:p>
           <a:p>
             <a:pPr lvl="1"/>
             <a:r>
-              <a:rPr lang="en-US" smtClean="0"/>
+              <a:rPr lang="en-US"/>
               <a:t>Second level</a:t>
             </a:r>
           </a:p>
           <a:p>
             <a:pPr lvl="2"/>
             <a:r>
-              <a:rPr lang="en-US" smtClean="0"/>
+              <a:rPr lang="en-US"/>
               <a:t>Third level</a:t>
             </a:r>
           </a:p>
           <a:p>
             <a:pPr lvl="3"/>
             <a:r>
-              <a:rPr lang="en-US" smtClean="0"/>
+              <a:rPr lang="en-US"/>
               <a:t>Fourth level</a:t>
             </a:r>
           </a:p>
           <a:p>
             <a:pPr lvl="4"/>
             <a:r>
-              <a:rPr lang="en-US" smtClean="0"/>
+              <a:rPr lang="en-US"/>
               <a:t>Fifth level</a:t>
             </a:r>
-            <a:endParaRPr lang="en-US"/>
           </a:p>
         </p:txBody>
       </p:sp>
@@ -2720,7 +2715,7 @@
           <a:p>
             <a:fld id="{5BCAD085-E8A6-8845-BD4E-CB4CCA059FC4}" type="datetimeFigureOut">
               <a:rPr lang="en-US" smtClean="0"/>
-              <a:t>1/27/13</a:t>
+              <a:t>5/11/26</a:t>
             </a:fld>
             <a:endParaRPr lang="en-US"/>
           </a:p>
@@ -3079,7 +3074,7 @@
 </file>
 
 <file path=ppt/slides/slide1.xml><?xml version="1.0" encoding="utf-8"?>
-<p:sld xmlns:a="http://schemas.openxmlformats.org/drawingml/2006/main" xmlns:p="http://schemas.openxmlformats.org/presentationml/2006/main" xmlns:r="http://schemas.openxmlformats.org/officeDocument/2006/relationships">
+<p:sld xmlns:a="http://schemas.openxmlformats.org/drawingml/2006/main" xmlns:r="http://schemas.openxmlformats.org/officeDocument/2006/relationships" xmlns:p="http://schemas.openxmlformats.org/presentationml/2006/main">
   <p:cSld>
     <p:spTree>
       <p:nvGrpSpPr>
@@ -3087,7 +3082,14 @@
         <p:cNvGrpSpPr/>
         <p:nvPr/>
       </p:nvGrpSpPr>
-      <p:grpSpPr/>
+      <p:grpSpPr>
+        <a:xfrm>
+          <a:off x="0" y="0"/>
+          <a:ext cx="0" cy="0"/>
+          <a:chOff x="0" y="0"/>
+          <a:chExt cx="0" cy="0"/>
+        </a:xfrm>
+      </p:grpSpPr>
       <p:sp>
         <p:nvSpPr>
           <p:cNvPr id="2" name="TextBox 1"/>
@@ -3105,7 +3107,7 @@
           <a:noFill/>
         </p:spPr>
         <p:txBody>
-          <a:bodyPr wrap="square" lIns="28575" rIns="28575" tIns="9525" bIns="9525" anchor="t">
+          <a:bodyPr wrap="square" lIns="28575" tIns="9525" rIns="28575" bIns="9525" anchor="t">
             <a:spAutoFit/>
           </a:bodyPr>
           <a:lstStyle/>
@@ -3140,7 +3142,7 @@
           <a:noFill/>
         </p:spPr>
         <p:txBody>
-          <a:bodyPr wrap="square" lIns="28575" rIns="28575" tIns="9525" bIns="9525" anchor="t">
+          <a:bodyPr wrap="square" lIns="28575" tIns="9525" rIns="28575" bIns="9525" anchor="t">
             <a:spAutoFit/>
           </a:bodyPr>
           <a:lstStyle/>
@@ -3199,6 +3201,7 @@
           <a:lstStyle/>
           <a:p>
             <a:pPr algn="ctr"/>
+            <a:endParaRPr/>
           </a:p>
         </p:txBody>
       </p:sp>
@@ -3219,7 +3222,7 @@
           <a:noFill/>
         </p:spPr>
         <p:txBody>
-          <a:bodyPr wrap="square" lIns="28575" rIns="28575" tIns="9525" bIns="9525" anchor="t">
+          <a:bodyPr wrap="square" lIns="28575" tIns="9525" rIns="28575" bIns="9525" anchor="t">
             <a:spAutoFit/>
           </a:bodyPr>
           <a:lstStyle/>
@@ -3292,6 +3295,7 @@
           <a:lstStyle/>
           <a:p>
             <a:pPr algn="ctr"/>
+            <a:endParaRPr/>
           </a:p>
         </p:txBody>
       </p:sp>
@@ -3312,7 +3316,7 @@
           <a:noFill/>
         </p:spPr>
         <p:txBody>
-          <a:bodyPr wrap="square" lIns="28575" rIns="28575" tIns="9525" bIns="9525" anchor="t">
+          <a:bodyPr wrap="square" lIns="28575" tIns="9525" rIns="28575" bIns="9525" anchor="t">
             <a:spAutoFit/>
           </a:bodyPr>
           <a:lstStyle/>
@@ -3367,7 +3371,7 @@
           </a:fontRef>
         </p:style>
         <p:txBody>
-          <a:bodyPr rtlCol="0" anchor="ctr" lIns="28575" rIns="28575" tIns="9525" bIns="9525" wrap="square"/>
+          <a:bodyPr wrap="square" lIns="28575" tIns="9525" rIns="28575" bIns="9525" rtlCol="0" anchor="ctr"/>
           <a:lstStyle/>
           <a:p>
             <a:pPr algn="ctr"/>
@@ -3422,7 +3426,7 @@
           </a:fontRef>
         </p:style>
         <p:txBody>
-          <a:bodyPr rtlCol="0" anchor="ctr" lIns="28575" rIns="28575" tIns="9525" bIns="9525" wrap="square"/>
+          <a:bodyPr wrap="square" lIns="28575" tIns="9525" rIns="28575" bIns="9525" rtlCol="0" anchor="ctr"/>
           <a:lstStyle/>
           <a:p>
             <a:pPr algn="ctr"/>
@@ -3475,7 +3479,7 @@
           </a:fontRef>
         </p:style>
         <p:txBody>
-          <a:bodyPr rtlCol="0" anchor="ctr" lIns="28575" rIns="28575" tIns="9525" bIns="9525" wrap="square"/>
+          <a:bodyPr wrap="square" lIns="28575" tIns="9525" rIns="28575" bIns="9525" rtlCol="0" anchor="ctr"/>
           <a:lstStyle/>
           <a:p>
             <a:pPr algn="ctr"/>
@@ -3520,7 +3524,7 @@
           <a:noFill/>
         </p:spPr>
         <p:txBody>
-          <a:bodyPr wrap="square" lIns="28575" rIns="28575" tIns="9525" bIns="9525" anchor="t">
+          <a:bodyPr wrap="square" lIns="28575" tIns="9525" rIns="28575" bIns="9525" anchor="t">
             <a:spAutoFit/>
           </a:bodyPr>
           <a:lstStyle/>
@@ -3555,7 +3559,7 @@
           <a:noFill/>
         </p:spPr>
         <p:txBody>
-          <a:bodyPr wrap="square" lIns="28575" rIns="28575" tIns="9525" bIns="9525" anchor="t">
+          <a:bodyPr wrap="square" lIns="28575" tIns="9525" rIns="28575" bIns="9525" anchor="t">
             <a:spAutoFit/>
           </a:bodyPr>
           <a:lstStyle/>
@@ -3590,7 +3594,7 @@
           <a:noFill/>
         </p:spPr>
         <p:txBody>
-          <a:bodyPr wrap="square" lIns="28575" rIns="28575" tIns="9525" bIns="9525" anchor="ctr">
+          <a:bodyPr wrap="square" lIns="28575" tIns="9525" rIns="28575" bIns="9525" anchor="ctr">
             <a:spAutoFit/>
           </a:bodyPr>
           <a:lstStyle/>
@@ -3625,7 +3629,7 @@
           <a:noFill/>
         </p:spPr>
         <p:txBody>
-          <a:bodyPr wrap="square" lIns="28575" rIns="28575" tIns="9525" bIns="9525" anchor="ctr">
+          <a:bodyPr wrap="square" lIns="28575" tIns="9525" rIns="28575" bIns="9525" anchor="ctr">
             <a:spAutoFit/>
           </a:bodyPr>
           <a:lstStyle/>
@@ -3680,7 +3684,7 @@
           </a:fontRef>
         </p:style>
         <p:txBody>
-          <a:bodyPr rtlCol="0" anchor="ctr" lIns="28575" rIns="28575" tIns="9525" bIns="9525" wrap="square"/>
+          <a:bodyPr wrap="square" lIns="28575" tIns="9525" rIns="28575" bIns="9525" rtlCol="0" anchor="ctr"/>
           <a:lstStyle/>
           <a:p>
             <a:pPr algn="ctr"/>
@@ -3733,7 +3737,7 @@
           </a:fontRef>
         </p:style>
         <p:txBody>
-          <a:bodyPr rtlCol="0" anchor="ctr" lIns="28575" rIns="28575" tIns="9525" bIns="9525" wrap="square"/>
+          <a:bodyPr wrap="square" lIns="28575" tIns="9525" rIns="28575" bIns="9525" rtlCol="0" anchor="ctr"/>
           <a:lstStyle/>
           <a:p>
             <a:pPr algn="ctr"/>
@@ -3793,6 +3797,7 @@
           <a:lstStyle/>
           <a:p>
             <a:pPr algn="ctr"/>
+            <a:endParaRPr/>
           </a:p>
         </p:txBody>
       </p:sp>
@@ -3813,7 +3818,7 @@
           <a:noFill/>
         </p:spPr>
         <p:txBody>
-          <a:bodyPr wrap="square" lIns="28575" rIns="28575" tIns="9525" bIns="9525" anchor="ctr">
+          <a:bodyPr wrap="square" lIns="28575" tIns="9525" rIns="28575" bIns="9525" anchor="ctr">
             <a:spAutoFit/>
           </a:bodyPr>
           <a:lstStyle/>
@@ -3884,7 +3889,7 @@
           </a:fontRef>
         </p:style>
         <p:txBody>
-          <a:bodyPr rtlCol="0" anchor="ctr" lIns="28575" rIns="28575" tIns="9525" bIns="9525" wrap="square"/>
+          <a:bodyPr wrap="square" lIns="28575" tIns="9525" rIns="28575" bIns="9525" rtlCol="0" anchor="ctr"/>
           <a:lstStyle/>
           <a:p>
             <a:pPr algn="ctr"/>
@@ -3951,7 +3956,7 @@
           </a:fontRef>
         </p:style>
         <p:txBody>
-          <a:bodyPr rtlCol="0" anchor="ctr" lIns="28575" rIns="28575" tIns="9525" bIns="9525" wrap="square"/>
+          <a:bodyPr wrap="square" lIns="28575" tIns="9525" rIns="28575" bIns="9525" rtlCol="0" anchor="ctr"/>
           <a:lstStyle/>
           <a:p>
             <a:pPr algn="ctr"/>
@@ -4004,7 +4009,7 @@
           </a:fontRef>
         </p:style>
         <p:txBody>
-          <a:bodyPr rtlCol="0" anchor="ctr" lIns="28575" rIns="28575" tIns="9525" bIns="9525" wrap="square"/>
+          <a:bodyPr wrap="square" lIns="28575" tIns="9525" rIns="28575" bIns="9525" rtlCol="0" anchor="ctr"/>
           <a:lstStyle/>
           <a:p>
             <a:pPr algn="ctr"/>
@@ -4095,7 +4100,7 @@
           </a:fontRef>
         </p:style>
         <p:txBody>
-          <a:bodyPr rtlCol="0" anchor="ctr" lIns="28575" rIns="28575" tIns="9525" bIns="9525" wrap="square"/>
+          <a:bodyPr wrap="square" lIns="28575" tIns="9525" rIns="28575" bIns="9525" rtlCol="0" anchor="ctr"/>
           <a:lstStyle/>
           <a:p>
             <a:pPr algn="ctr"/>
@@ -4188,7 +4193,7 @@
           </a:fontRef>
         </p:style>
         <p:txBody>
-          <a:bodyPr rtlCol="0" anchor="ctr" lIns="28575" rIns="28575" tIns="9525" bIns="9525" wrap="square"/>
+          <a:bodyPr wrap="square" lIns="28575" tIns="9525" rIns="28575" bIns="9525" rtlCol="0" anchor="ctr"/>
           <a:lstStyle/>
           <a:p>
             <a:pPr algn="ctr"/>
@@ -4255,7 +4260,7 @@
           </a:fontRef>
         </p:style>
         <p:txBody>
-          <a:bodyPr rtlCol="0" anchor="ctr" lIns="28575" rIns="28575" tIns="9525" bIns="9525" wrap="square"/>
+          <a:bodyPr wrap="square" lIns="28575" tIns="9525" rIns="28575" bIns="9525" rtlCol="0" anchor="ctr"/>
           <a:lstStyle/>
           <a:p>
             <a:pPr algn="ctr"/>
@@ -4308,7 +4313,7 @@
           </a:fontRef>
         </p:style>
         <p:txBody>
-          <a:bodyPr rtlCol="0" anchor="ctr" lIns="28575" rIns="28575" tIns="9525" bIns="9525" wrap="square"/>
+          <a:bodyPr wrap="square" lIns="28575" tIns="9525" rIns="28575" bIns="9525" rtlCol="0" anchor="ctr"/>
           <a:lstStyle/>
           <a:p>
             <a:pPr algn="ctr"/>
@@ -4399,7 +4404,7 @@
           </a:fontRef>
         </p:style>
         <p:txBody>
-          <a:bodyPr rtlCol="0" anchor="ctr" lIns="28575" rIns="28575" tIns="9525" bIns="9525" wrap="square"/>
+          <a:bodyPr wrap="square" lIns="28575" tIns="9525" rIns="28575" bIns="9525" rtlCol="0" anchor="ctr"/>
           <a:lstStyle/>
           <a:p>
             <a:pPr algn="ctr"/>
@@ -4492,7 +4497,7 @@
           </a:fontRef>
         </p:style>
         <p:txBody>
-          <a:bodyPr rtlCol="0" anchor="ctr" lIns="28575" rIns="28575" tIns="9525" bIns="9525" wrap="square"/>
+          <a:bodyPr wrap="square" lIns="28575" tIns="9525" rIns="28575" bIns="9525" rtlCol="0" anchor="ctr"/>
           <a:lstStyle/>
           <a:p>
             <a:pPr algn="ctr"/>
@@ -4559,7 +4564,7 @@
           </a:fontRef>
         </p:style>
         <p:txBody>
-          <a:bodyPr rtlCol="0" anchor="ctr" lIns="28575" rIns="28575" tIns="9525" bIns="9525" wrap="square"/>
+          <a:bodyPr wrap="square" lIns="28575" tIns="9525" rIns="28575" bIns="9525" rtlCol="0" anchor="ctr"/>
           <a:lstStyle/>
           <a:p>
             <a:pPr algn="ctr"/>
@@ -4652,7 +4657,7 @@
           </a:fontRef>
         </p:style>
         <p:txBody>
-          <a:bodyPr rtlCol="0" anchor="ctr" lIns="28575" rIns="28575" tIns="9525" bIns="9525" wrap="square"/>
+          <a:bodyPr wrap="square" lIns="28575" tIns="9525" rIns="28575" bIns="9525" rtlCol="0" anchor="ctr"/>
           <a:lstStyle/>
           <a:p>
             <a:pPr algn="ctr"/>
@@ -4719,7 +4724,7 @@
           </a:fontRef>
         </p:style>
         <p:txBody>
-          <a:bodyPr rtlCol="0" anchor="ctr" lIns="28575" rIns="28575" tIns="9525" bIns="9525" wrap="square"/>
+          <a:bodyPr wrap="square" lIns="28575" tIns="9525" rIns="28575" bIns="9525" rtlCol="0" anchor="ctr"/>
           <a:lstStyle/>
           <a:p>
             <a:pPr algn="ctr"/>
@@ -4772,7 +4777,7 @@
           </a:fontRef>
         </p:style>
         <p:txBody>
-          <a:bodyPr rtlCol="0" anchor="ctr" lIns="28575" rIns="28575" tIns="9525" bIns="9525" wrap="square"/>
+          <a:bodyPr wrap="square" lIns="28575" tIns="9525" rIns="28575" bIns="9525" rtlCol="0" anchor="ctr"/>
           <a:lstStyle/>
           <a:p>
             <a:pPr algn="ctr"/>
@@ -4831,6 +4836,7 @@
           <a:lstStyle/>
           <a:p>
             <a:pPr algn="ctr"/>
+            <a:endParaRPr/>
           </a:p>
         </p:txBody>
       </p:sp>
@@ -4851,7 +4857,7 @@
           <a:noFill/>
         </p:spPr>
         <p:txBody>
-          <a:bodyPr wrap="square" lIns="28575" rIns="28575" tIns="9525" bIns="9525" anchor="t">
+          <a:bodyPr wrap="square" lIns="28575" tIns="9525" rIns="28575" bIns="9525" anchor="t">
             <a:spAutoFit/>
           </a:bodyPr>
           <a:lstStyle/>
@@ -4954,7 +4960,7 @@
           </a:fontRef>
         </p:style>
         <p:txBody>
-          <a:bodyPr rtlCol="0" anchor="ctr" lIns="28575" rIns="28575" tIns="9525" bIns="9525" wrap="square"/>
+          <a:bodyPr wrap="square" lIns="28575" tIns="9525" rIns="28575" bIns="9525" rtlCol="0" anchor="ctr"/>
           <a:lstStyle/>
           <a:p>
             <a:pPr algn="ctr"/>
@@ -4987,7 +4993,7 @@
           <a:noFill/>
         </p:spPr>
         <p:txBody>
-          <a:bodyPr wrap="square" lIns="28575" rIns="28575" tIns="9525" bIns="9525" anchor="ctr">
+          <a:bodyPr wrap="square" lIns="28575" tIns="9525" rIns="28575" bIns="9525" anchor="ctr">
             <a:spAutoFit/>
           </a:bodyPr>
           <a:lstStyle/>
@@ -5058,7 +5064,7 @@
           </a:fontRef>
         </p:style>
         <p:txBody>
-          <a:bodyPr rtlCol="0" anchor="ctr" lIns="28575" rIns="28575" tIns="9525" bIns="9525" wrap="square"/>
+          <a:bodyPr wrap="square" lIns="28575" tIns="9525" rIns="28575" bIns="9525" rtlCol="0" anchor="ctr"/>
           <a:lstStyle/>
           <a:p>
             <a:pPr algn="ctr"/>
@@ -5125,7 +5131,7 @@
           </a:fontRef>
         </p:style>
         <p:txBody>
-          <a:bodyPr rtlCol="0" anchor="ctr" lIns="28575" rIns="28575" tIns="9525" bIns="9525" wrap="square"/>
+          <a:bodyPr wrap="square" lIns="28575" tIns="9525" rIns="28575" bIns="9525" rtlCol="0" anchor="ctr"/>
           <a:lstStyle/>
           <a:p>
             <a:pPr algn="ctr"/>
@@ -5178,7 +5184,7 @@
           </a:fontRef>
         </p:style>
         <p:txBody>
-          <a:bodyPr rtlCol="0" anchor="ctr" lIns="28575" rIns="28575" tIns="9525" bIns="9525" wrap="square"/>
+          <a:bodyPr wrap="square" lIns="28575" tIns="9525" rIns="28575" bIns="9525" rtlCol="0" anchor="ctr"/>
           <a:lstStyle/>
           <a:p>
             <a:pPr algn="ctr"/>
@@ -5269,7 +5275,7 @@
           </a:fontRef>
         </p:style>
         <p:txBody>
-          <a:bodyPr rtlCol="0" anchor="ctr" lIns="28575" rIns="28575" tIns="9525" bIns="9525" wrap="square"/>
+          <a:bodyPr wrap="square" lIns="28575" tIns="9525" rIns="28575" bIns="9525" rtlCol="0" anchor="ctr"/>
           <a:lstStyle/>
           <a:p>
             <a:pPr algn="ctr"/>
@@ -5362,7 +5368,7 @@
           </a:fontRef>
         </p:style>
         <p:txBody>
-          <a:bodyPr rtlCol="0" anchor="ctr" lIns="28575" rIns="28575" tIns="9525" bIns="9525" wrap="square"/>
+          <a:bodyPr wrap="square" lIns="28575" tIns="9525" rIns="28575" bIns="9525" rtlCol="0" anchor="ctr"/>
           <a:lstStyle/>
           <a:p>
             <a:pPr algn="ctr"/>
@@ -5429,7 +5435,7 @@
           </a:fontRef>
         </p:style>
         <p:txBody>
-          <a:bodyPr rtlCol="0" anchor="ctr" lIns="28575" rIns="28575" tIns="9525" bIns="9525" wrap="square"/>
+          <a:bodyPr wrap="square" lIns="28575" tIns="9525" rIns="28575" bIns="9525" rtlCol="0" anchor="ctr"/>
           <a:lstStyle/>
           <a:p>
             <a:pPr algn="ctr"/>
@@ -5482,7 +5488,7 @@
           </a:fontRef>
         </p:style>
         <p:txBody>
-          <a:bodyPr rtlCol="0" anchor="ctr" lIns="28575" rIns="28575" tIns="9525" bIns="9525" wrap="square"/>
+          <a:bodyPr wrap="square" lIns="28575" tIns="9525" rIns="28575" bIns="9525" rtlCol="0" anchor="ctr"/>
           <a:lstStyle/>
           <a:p>
             <a:pPr algn="ctr"/>
@@ -5573,7 +5579,7 @@
           </a:fontRef>
         </p:style>
         <p:txBody>
-          <a:bodyPr rtlCol="0" anchor="ctr" lIns="28575" rIns="28575" tIns="9525" bIns="9525" wrap="square"/>
+          <a:bodyPr wrap="square" lIns="28575" tIns="9525" rIns="28575" bIns="9525" rtlCol="0" anchor="ctr"/>
           <a:lstStyle/>
           <a:p>
             <a:pPr algn="ctr"/>
@@ -5666,7 +5672,7 @@
           </a:fontRef>
         </p:style>
         <p:txBody>
-          <a:bodyPr rtlCol="0" anchor="ctr" lIns="28575" rIns="28575" tIns="9525" bIns="9525" wrap="square"/>
+          <a:bodyPr wrap="square" lIns="28575" tIns="9525" rIns="28575" bIns="9525" rtlCol="0" anchor="ctr"/>
           <a:lstStyle/>
           <a:p>
             <a:pPr algn="ctr"/>
@@ -5733,7 +5739,7 @@
           </a:fontRef>
         </p:style>
         <p:txBody>
-          <a:bodyPr rtlCol="0" anchor="ctr" lIns="28575" rIns="28575" tIns="9525" bIns="9525" wrap="square"/>
+          <a:bodyPr wrap="square" lIns="28575" tIns="9525" rIns="28575" bIns="9525" rtlCol="0" anchor="ctr"/>
           <a:lstStyle/>
           <a:p>
             <a:pPr algn="ctr"/>
@@ -5826,7 +5832,7 @@
           </a:fontRef>
         </p:style>
         <p:txBody>
-          <a:bodyPr rtlCol="0" anchor="ctr" lIns="28575" rIns="28575" tIns="9525" bIns="9525" wrap="square"/>
+          <a:bodyPr wrap="square" lIns="28575" tIns="9525" rIns="28575" bIns="9525" rtlCol="0" anchor="ctr"/>
           <a:lstStyle/>
           <a:p>
             <a:pPr algn="ctr"/>
@@ -5893,7 +5899,7 @@
           </a:fontRef>
         </p:style>
         <p:txBody>
-          <a:bodyPr rtlCol="0" anchor="ctr" lIns="28575" rIns="28575" tIns="9525" bIns="9525" wrap="square"/>
+          <a:bodyPr wrap="square" lIns="28575" tIns="9525" rIns="28575" bIns="9525" rtlCol="0" anchor="ctr"/>
           <a:lstStyle/>
           <a:p>
             <a:pPr algn="ctr"/>
@@ -5946,7 +5952,7 @@
           </a:fontRef>
         </p:style>
         <p:txBody>
-          <a:bodyPr rtlCol="0" anchor="ctr" lIns="28575" rIns="28575" tIns="9525" bIns="9525" wrap="square"/>
+          <a:bodyPr wrap="square" lIns="28575" tIns="9525" rIns="28575" bIns="9525" rtlCol="0" anchor="ctr"/>
           <a:lstStyle/>
           <a:p>
             <a:pPr algn="ctr"/>
@@ -6039,7 +6045,7 @@
           </a:fontRef>
         </p:style>
         <p:txBody>
-          <a:bodyPr rtlCol="0" anchor="ctr" lIns="28575" rIns="28575" tIns="9525" bIns="9525" wrap="square"/>
+          <a:bodyPr wrap="square" lIns="28575" tIns="9525" rIns="28575" bIns="9525" rtlCol="0" anchor="ctr"/>
           <a:lstStyle/>
           <a:p>
             <a:pPr algn="ctr"/>
@@ -6106,7 +6112,7 @@
           </a:fontRef>
         </p:style>
         <p:txBody>
-          <a:bodyPr rtlCol="0" anchor="ctr" lIns="28575" rIns="28575" tIns="9525" bIns="9525" wrap="square"/>
+          <a:bodyPr wrap="square" lIns="28575" tIns="9525" rIns="28575" bIns="9525" rtlCol="0" anchor="ctr"/>
           <a:lstStyle/>
           <a:p>
             <a:pPr algn="ctr"/>
@@ -6159,7 +6165,7 @@
           </a:fontRef>
         </p:style>
         <p:txBody>
-          <a:bodyPr rtlCol="0" anchor="ctr" lIns="28575" rIns="28575" tIns="9525" bIns="9525" wrap="square"/>
+          <a:bodyPr wrap="square" lIns="28575" tIns="9525" rIns="28575" bIns="9525" rtlCol="0" anchor="ctr"/>
           <a:lstStyle/>
           <a:p>
             <a:pPr algn="ctr"/>
@@ -6218,6 +6224,7 @@
           <a:lstStyle/>
           <a:p>
             <a:pPr algn="ctr"/>
+            <a:endParaRPr/>
           </a:p>
         </p:txBody>
       </p:sp>
@@ -6238,7 +6245,7 @@
           <a:noFill/>
         </p:spPr>
         <p:txBody>
-          <a:bodyPr wrap="square" lIns="28575" rIns="28575" tIns="9525" bIns="9525" anchor="t">
+          <a:bodyPr wrap="square" lIns="28575" tIns="9525" rIns="28575" bIns="9525" anchor="t">
             <a:spAutoFit/>
           </a:bodyPr>
           <a:lstStyle/>
@@ -6333,7 +6340,7 @@
           </a:fontRef>
         </p:style>
         <p:txBody>
-          <a:bodyPr rtlCol="0" anchor="ctr" lIns="28575" rIns="28575" tIns="9525" bIns="9525" wrap="square"/>
+          <a:bodyPr wrap="square" lIns="28575" tIns="9525" rIns="28575" bIns="9525" rtlCol="0" anchor="ctr"/>
           <a:lstStyle/>
           <a:p>
             <a:pPr algn="ctr"/>
@@ -6388,7 +6395,7 @@
           </a:fontRef>
         </p:style>
         <p:txBody>
-          <a:bodyPr rtlCol="0" anchor="ctr" lIns="28575" rIns="28575" tIns="9525" bIns="9525" wrap="square"/>
+          <a:bodyPr wrap="square" lIns="28575" tIns="9525" rIns="28575" bIns="9525" rtlCol="0" anchor="ctr"/>
           <a:lstStyle/>
           <a:p>
             <a:pPr algn="ctr"/>
@@ -6441,7 +6448,7 @@
           </a:fontRef>
         </p:style>
         <p:txBody>
-          <a:bodyPr rtlCol="0" anchor="ctr" lIns="28575" rIns="28575" tIns="9525" bIns="9525" wrap="square"/>
+          <a:bodyPr wrap="square" lIns="28575" tIns="9525" rIns="28575" bIns="9525" rtlCol="0" anchor="ctr"/>
           <a:lstStyle/>
           <a:p>
             <a:pPr algn="ctr"/>
@@ -6572,6 +6579,7 @@
           <a:lstStyle/>
           <a:p>
             <a:pPr algn="ctr"/>
+            <a:endParaRPr/>
           </a:p>
         </p:txBody>
       </p:sp>
@@ -6592,7 +6600,7 @@
           <a:noFill/>
         </p:spPr>
         <p:txBody>
-          <a:bodyPr wrap="square" lIns="28575" rIns="28575" tIns="9525" bIns="9525" anchor="t">
+          <a:bodyPr wrap="square" lIns="28575" tIns="9525" rIns="28575" bIns="9525" anchor="t">
             <a:spAutoFit/>
           </a:bodyPr>
           <a:lstStyle/>
@@ -6707,7 +6715,7 @@
           </a:fontRef>
         </p:style>
         <p:txBody>
-          <a:bodyPr rtlCol="0" anchor="ctr" lIns="28575" rIns="28575" tIns="9525" bIns="9525" wrap="square"/>
+          <a:bodyPr wrap="square" lIns="28575" tIns="9525" rIns="28575" bIns="9525" rtlCol="0" anchor="ctr"/>
           <a:lstStyle/>
           <a:p>
             <a:pPr algn="ctr"/>
@@ -6766,6 +6774,7 @@
           <a:lstStyle/>
           <a:p>
             <a:pPr algn="ctr"/>
+            <a:endParaRPr/>
           </a:p>
         </p:txBody>
       </p:sp>
@@ -6786,7 +6795,7 @@
           <a:noFill/>
         </p:spPr>
         <p:txBody>
-          <a:bodyPr wrap="square" lIns="28575" rIns="28575" tIns="9525" bIns="9525" anchor="t">
+          <a:bodyPr wrap="square" lIns="28575" tIns="9525" rIns="28575" bIns="9525" anchor="t">
             <a:spAutoFit/>
           </a:bodyPr>
           <a:lstStyle/>
@@ -6901,7 +6910,7 @@
           </a:fontRef>
         </p:style>
         <p:txBody>
-          <a:bodyPr rtlCol="0" anchor="ctr" lIns="28575" rIns="28575" tIns="9525" bIns="9525" wrap="square"/>
+          <a:bodyPr wrap="square" lIns="28575" tIns="9525" rIns="28575" bIns="9525" rtlCol="0" anchor="ctr"/>
           <a:lstStyle/>
           <a:p>
             <a:pPr algn="ctr"/>
@@ -6960,6 +6969,7 @@
           <a:lstStyle/>
           <a:p>
             <a:pPr algn="ctr"/>
+            <a:endParaRPr/>
           </a:p>
         </p:txBody>
       </p:sp>
@@ -6980,7 +6990,7 @@
           <a:noFill/>
         </p:spPr>
         <p:txBody>
-          <a:bodyPr wrap="square" lIns="28575" rIns="28575" tIns="9525" bIns="9525" anchor="t">
+          <a:bodyPr wrap="square" lIns="28575" tIns="9525" rIns="28575" bIns="9525" anchor="t">
             <a:spAutoFit/>
           </a:bodyPr>
           <a:lstStyle/>
@@ -7095,7 +7105,7 @@
           </a:fontRef>
         </p:style>
         <p:txBody>
-          <a:bodyPr rtlCol="0" anchor="ctr" lIns="28575" rIns="28575" tIns="9525" bIns="9525" wrap="square"/>
+          <a:bodyPr wrap="square" lIns="28575" tIns="9525" rIns="28575" bIns="9525" rtlCol="0" anchor="ctr"/>
           <a:lstStyle/>
           <a:p>
             <a:pPr algn="ctr"/>
@@ -7128,7 +7138,7 @@
           <a:noFill/>
         </p:spPr>
         <p:txBody>
-          <a:bodyPr wrap="square" lIns="28575" rIns="28575" tIns="9525" bIns="9525" anchor="t">
+          <a:bodyPr wrap="square" lIns="28575" tIns="9525" rIns="28575" bIns="9525" anchor="t">
             <a:spAutoFit/>
           </a:bodyPr>
           <a:lstStyle/>
@@ -7187,6 +7197,7 @@
           <a:lstStyle/>
           <a:p>
             <a:pPr algn="ctr"/>
+            <a:endParaRPr/>
           </a:p>
         </p:txBody>
       </p:sp>
@@ -7227,7 +7238,7 @@
           </a:fontRef>
         </p:style>
         <p:txBody>
-          <a:bodyPr rtlCol="0" anchor="ctr" lIns="28575" rIns="28575" tIns="9525" bIns="9525" wrap="square"/>
+          <a:bodyPr wrap="square" lIns="28575" tIns="9525" rIns="28575" bIns="9525" rtlCol="0" anchor="ctr"/>
           <a:lstStyle/>
           <a:p>
             <a:pPr algn="ctr"/>
@@ -7260,7 +7271,7 @@
           <a:noFill/>
         </p:spPr>
         <p:txBody>
-          <a:bodyPr wrap="square" lIns="28575" rIns="28575" tIns="9525" bIns="9525" anchor="t">
+          <a:bodyPr wrap="square" lIns="28575" tIns="9525" rIns="28575" bIns="9525" anchor="t">
             <a:spAutoFit/>
           </a:bodyPr>
           <a:lstStyle/>
@@ -7295,7 +7306,7 @@
           <a:noFill/>
         </p:spPr>
         <p:txBody>
-          <a:bodyPr wrap="square" lIns="28575" rIns="28575" tIns="9525" bIns="9525" anchor="t">
+          <a:bodyPr wrap="square" lIns="28575" tIns="9525" rIns="28575" bIns="9525" anchor="t">
             <a:spAutoFit/>
           </a:bodyPr>
           <a:lstStyle/>
@@ -7350,7 +7361,7 @@
           </a:fontRef>
         </p:style>
         <p:txBody>
-          <a:bodyPr rtlCol="0" anchor="ctr" lIns="28575" rIns="28575" tIns="9525" bIns="9525" wrap="square"/>
+          <a:bodyPr wrap="square" lIns="28575" tIns="9525" rIns="28575" bIns="9525" rtlCol="0" anchor="ctr"/>
           <a:lstStyle/>
           <a:p>
             <a:pPr algn="ctr"/>
@@ -7383,7 +7394,7 @@
           <a:noFill/>
         </p:spPr>
         <p:txBody>
-          <a:bodyPr wrap="square" lIns="28575" rIns="28575" tIns="9525" bIns="9525" anchor="t">
+          <a:bodyPr wrap="square" lIns="28575" tIns="9525" rIns="28575" bIns="9525" anchor="t">
             <a:spAutoFit/>
           </a:bodyPr>
           <a:lstStyle/>
@@ -7418,7 +7429,7 @@
           <a:noFill/>
         </p:spPr>
         <p:txBody>
-          <a:bodyPr wrap="square" lIns="28575" rIns="28575" tIns="9525" bIns="9525" anchor="t">
+          <a:bodyPr wrap="square" lIns="28575" tIns="9525" rIns="28575" bIns="9525" anchor="t">
             <a:spAutoFit/>
           </a:bodyPr>
           <a:lstStyle/>
@@ -7473,7 +7484,7 @@
           </a:fontRef>
         </p:style>
         <p:txBody>
-          <a:bodyPr rtlCol="0" anchor="ctr" lIns="28575" rIns="28575" tIns="9525" bIns="9525" wrap="square"/>
+          <a:bodyPr wrap="square" lIns="28575" tIns="9525" rIns="28575" bIns="9525" rtlCol="0" anchor="ctr"/>
           <a:lstStyle/>
           <a:p>
             <a:pPr algn="ctr"/>
@@ -7506,7 +7517,7 @@
           <a:noFill/>
         </p:spPr>
         <p:txBody>
-          <a:bodyPr wrap="square" lIns="28575" rIns="28575" tIns="9525" bIns="9525" anchor="t">
+          <a:bodyPr wrap="square" lIns="28575" tIns="9525" rIns="28575" bIns="9525" anchor="t">
             <a:spAutoFit/>
           </a:bodyPr>
           <a:lstStyle/>
@@ -7541,7 +7552,7 @@
           <a:noFill/>
         </p:spPr>
         <p:txBody>
-          <a:bodyPr wrap="square" lIns="28575" rIns="28575" tIns="9525" bIns="9525" anchor="t">
+          <a:bodyPr wrap="square" lIns="28575" tIns="9525" rIns="28575" bIns="9525" anchor="t">
             <a:spAutoFit/>
           </a:bodyPr>
           <a:lstStyle/>
@@ -7596,7 +7607,7 @@
           </a:fontRef>
         </p:style>
         <p:txBody>
-          <a:bodyPr rtlCol="0" anchor="ctr" lIns="28575" rIns="28575" tIns="9525" bIns="9525" wrap="square"/>
+          <a:bodyPr wrap="square" lIns="28575" tIns="9525" rIns="28575" bIns="9525" rtlCol="0" anchor="ctr"/>
           <a:lstStyle/>
           <a:p>
             <a:pPr algn="ctr"/>
@@ -7629,7 +7640,7 @@
           <a:noFill/>
         </p:spPr>
         <p:txBody>
-          <a:bodyPr wrap="square" lIns="28575" rIns="28575" tIns="9525" bIns="9525" anchor="t">
+          <a:bodyPr wrap="square" lIns="28575" tIns="9525" rIns="28575" bIns="9525" anchor="t">
             <a:spAutoFit/>
           </a:bodyPr>
           <a:lstStyle/>
@@ -7664,7 +7675,7 @@
           <a:noFill/>
         </p:spPr>
         <p:txBody>
-          <a:bodyPr wrap="square" lIns="28575" rIns="28575" tIns="9525" bIns="9525" anchor="t">
+          <a:bodyPr wrap="square" lIns="28575" tIns="9525" rIns="28575" bIns="9525" anchor="t">
             <a:spAutoFit/>
           </a:bodyPr>
           <a:lstStyle/>
@@ -7719,7 +7730,7 @@
           </a:fontRef>
         </p:style>
         <p:txBody>
-          <a:bodyPr rtlCol="0" anchor="ctr" lIns="28575" rIns="28575" tIns="9525" bIns="9525" wrap="square"/>
+          <a:bodyPr wrap="square" lIns="28575" tIns="9525" rIns="28575" bIns="9525" rtlCol="0" anchor="ctr"/>
           <a:lstStyle/>
           <a:p>
             <a:pPr algn="ctr"/>
@@ -7752,7 +7763,7 @@
           <a:noFill/>
         </p:spPr>
         <p:txBody>
-          <a:bodyPr wrap="square" lIns="28575" rIns="28575" tIns="9525" bIns="9525" anchor="t">
+          <a:bodyPr wrap="square" lIns="28575" tIns="9525" rIns="28575" bIns="9525" anchor="t">
             <a:spAutoFit/>
           </a:bodyPr>
           <a:lstStyle/>
@@ -7787,7 +7798,7 @@
           <a:noFill/>
         </p:spPr>
         <p:txBody>
-          <a:bodyPr wrap="square" lIns="28575" rIns="28575" tIns="9525" bIns="9525" anchor="t">
+          <a:bodyPr wrap="square" lIns="28575" tIns="9525" rIns="28575" bIns="9525" anchor="t">
             <a:spAutoFit/>
           </a:bodyPr>
           <a:lstStyle/>
@@ -7842,7 +7853,7 @@
           </a:fontRef>
         </p:style>
         <p:txBody>
-          <a:bodyPr rtlCol="0" anchor="ctr" lIns="28575" rIns="28575" tIns="9525" bIns="9525" wrap="square"/>
+          <a:bodyPr wrap="square" lIns="28575" tIns="9525" rIns="28575" bIns="9525" rtlCol="0" anchor="ctr"/>
           <a:lstStyle/>
           <a:p>
             <a:pPr algn="ctr"/>
@@ -7875,7 +7886,7 @@
           <a:noFill/>
         </p:spPr>
         <p:txBody>
-          <a:bodyPr wrap="square" lIns="28575" rIns="28575" tIns="9525" bIns="9525" anchor="t">
+          <a:bodyPr wrap="square" lIns="28575" tIns="9525" rIns="28575" bIns="9525" anchor="t">
             <a:spAutoFit/>
           </a:bodyPr>
           <a:lstStyle/>
@@ -7910,7 +7921,7 @@
           <a:noFill/>
         </p:spPr>
         <p:txBody>
-          <a:bodyPr wrap="square" lIns="28575" rIns="28575" tIns="9525" bIns="9525" anchor="t">
+          <a:bodyPr wrap="square" lIns="28575" tIns="9525" rIns="28575" bIns="9525" anchor="t">
             <a:spAutoFit/>
           </a:bodyPr>
           <a:lstStyle/>
@@ -7969,6 +7980,7 @@
           <a:lstStyle/>
           <a:p>
             <a:pPr algn="ctr"/>
+            <a:endParaRPr/>
           </a:p>
         </p:txBody>
       </p:sp>
@@ -8013,6 +8025,7 @@
           <a:lstStyle/>
           <a:p>
             <a:pPr algn="ctr"/>
+            <a:endParaRPr/>
           </a:p>
         </p:txBody>
       </p:sp>
@@ -8033,7 +8046,7 @@
           <a:noFill/>
         </p:spPr>
         <p:txBody>
-          <a:bodyPr wrap="square" lIns="28575" rIns="28575" tIns="9525" bIns="9525" anchor="ctr">
+          <a:bodyPr wrap="square" lIns="28575" tIns="9525" rIns="28575" bIns="9525" anchor="ctr">
             <a:spAutoFit/>
           </a:bodyPr>
           <a:lstStyle/>
@@ -8068,7 +8081,7 @@
           <a:noFill/>
         </p:spPr>
         <p:txBody>
-          <a:bodyPr wrap="square" lIns="28575" rIns="28575" tIns="9525" bIns="9525" anchor="ctr">
+          <a:bodyPr wrap="square" lIns="28575" tIns="9525" rIns="28575" bIns="9525" anchor="ctr">
             <a:spAutoFit/>
           </a:bodyPr>
           <a:lstStyle/>
@@ -8103,7 +8116,7 @@
           <a:noFill/>
         </p:spPr>
         <p:txBody>
-          <a:bodyPr wrap="square" lIns="28575" rIns="28575" tIns="9525" bIns="9525" anchor="t">
+          <a:bodyPr wrap="square" lIns="28575" tIns="9525" rIns="28575" bIns="9525" anchor="t">
             <a:spAutoFit/>
           </a:bodyPr>
           <a:lstStyle/>
@@ -8150,7 +8163,7 @@
           <a:noFill/>
         </p:spPr>
         <p:txBody>
-          <a:bodyPr wrap="square" lIns="28575" rIns="28575" tIns="9525" bIns="9525" anchor="t">
+          <a:bodyPr wrap="square" lIns="28575" tIns="9525" rIns="28575" bIns="9525" anchor="t">
             <a:spAutoFit/>
           </a:bodyPr>
           <a:lstStyle/>

</xml_diff>